<commit_message>
Update author name to Shristi Kumar across all project files
Updated author attribution from Abhishek Kumar to Shristi Kumar in:
- All README files (root and policyforge/)
- Gamma presentation prompts
- Generation scripts (Word and PowerPoint)
- Technical documentation
- Regenerated Word report and PowerPoint presentation with correct name
- Added 12-slide Gamma prompt for concise presentation

Co-authored-by: Cursor <cursoragent@cursor.com>
</commit_message>
<xml_diff>
--- a/PolicyForge_Presentation.pptx
+++ b/PolicyForge_Presentation.pptx
@@ -3263,7 +3263,7 @@
                 </a:solidFill>
                 <a:latin typeface="Arial"/>
               </a:rPr>
-              <a:t>Abhishek Kumar</a:t>
+              <a:t>Shristi Kumar</a:t>
             </a:r>
             <a:br/>
             <a:r>
@@ -3377,7 +3377,7 @@
                 </a:solidFill>
                 <a:latin typeface="Arial"/>
               </a:rPr>
-              <a:t>PolicyForge | Abhishek Kumar | Cotiviti Assessment</a:t>
+              <a:t>PolicyForge | Shristi Kumar | Cotiviti Assessment</a:t>
             </a:r>
           </a:p>
         </p:txBody>
@@ -3712,7 +3712,7 @@
                 </a:solidFill>
                 <a:latin typeface="Arial"/>
               </a:rPr>
-              <a:t>PolicyForge | Abhishek Kumar | Cotiviti Assessment</a:t>
+              <a:t>PolicyForge | Shristi Kumar | Cotiviti Assessment</a:t>
             </a:r>
           </a:p>
         </p:txBody>
@@ -4039,7 +4039,7 @@
                 </a:solidFill>
                 <a:latin typeface="Arial"/>
               </a:rPr>
-              <a:t>PolicyForge | Abhishek Kumar | Cotiviti Assessment</a:t>
+              <a:t>PolicyForge | Shristi Kumar | Cotiviti Assessment</a:t>
             </a:r>
           </a:p>
         </p:txBody>
@@ -4637,7 +4637,7 @@
                 </a:solidFill>
                 <a:latin typeface="Arial"/>
               </a:rPr>
-              <a:t>PolicyForge | Abhishek Kumar | Cotiviti Assessment</a:t>
+              <a:t>PolicyForge | Shristi Kumar | Cotiviti Assessment</a:t>
             </a:r>
           </a:p>
         </p:txBody>
@@ -5982,7 +5982,7 @@
                 </a:solidFill>
                 <a:latin typeface="Arial"/>
               </a:rPr>
-              <a:t>PolicyForge | Abhishek Kumar | Cotiviti Assessment</a:t>
+              <a:t>PolicyForge | Shristi Kumar | Cotiviti Assessment</a:t>
             </a:r>
           </a:p>
         </p:txBody>
@@ -6538,7 +6538,7 @@
                 </a:solidFill>
                 <a:latin typeface="Arial"/>
               </a:rPr>
-              <a:t>PolicyForge | Abhishek Kumar | Cotiviti Assessment</a:t>
+              <a:t>PolicyForge | Shristi Kumar | Cotiviti Assessment</a:t>
             </a:r>
           </a:p>
         </p:txBody>
@@ -6902,7 +6902,7 @@
                 </a:solidFill>
                 <a:latin typeface="Arial"/>
               </a:rPr>
-              <a:t>PolicyForge | Abhishek Kumar | Cotiviti Assessment</a:t>
+              <a:t>PolicyForge | Shristi Kumar | Cotiviti Assessment</a:t>
             </a:r>
           </a:p>
         </p:txBody>
@@ -7497,7 +7497,7 @@
                 </a:solidFill>
                 <a:latin typeface="Arial"/>
               </a:rPr>
-              <a:t>PolicyForge | Abhishek Kumar | Cotiviti Assessment</a:t>
+              <a:t>PolicyForge | Shristi Kumar | Cotiviti Assessment</a:t>
             </a:r>
           </a:p>
         </p:txBody>
@@ -8082,7 +8082,7 @@
                 </a:solidFill>
                 <a:latin typeface="Arial"/>
               </a:rPr>
-              <a:t>PolicyForge | Abhishek Kumar | Cotiviti Assessment</a:t>
+              <a:t>PolicyForge | Shristi Kumar | Cotiviti Assessment</a:t>
             </a:r>
           </a:p>
         </p:txBody>

</xml_diff>